<commit_message>
docs: proposal share-risk - PA-1 fund phan B, PA-2 fund B+C, rev-share 2 nam roi co phan
PA-1 (~829M): NDT 40-45% rev-share T03/27-T03/29, ~10-15% co phan sau.
PA-2 (~1995M): NDT 60-65% rev-share, ~20-25% co phan sau.
Recoup-first trong cua so 2 nam; co phan vesting tu ngay ky.

Generated with [Devin](https://devin.ai)

Co-Authored-By: Devin <158243242+devin-ai-integration[bot]@users.noreply.github.com>
</commit_message>
<xml_diff>
--- a/docs/handover/PROPOSAL-tong-dau-tu-2ty8.pptx
+++ b/docs/handover/PROPOSAL-tong-dau-tu-2ty8.pptx
@@ -14756,7 +14756,7 @@
                 <a:ea typeface="Segoe UI" pitchFamily="34" charset="-122"/>
                 <a:cs typeface="Segoe UI" pitchFamily="34" charset="-120"/>
               </a:rPr>
-              <a:t>PHƯƠNG ÁN SHARE-RISK</a:t>
+              <a:t>PHƯƠNG ÁN KÊU GỌI &amp; CHIA SẺ</a:t>
             </a:r>
             <a:endParaRPr lang="en-US" sz="1100" dirty="0"/>
           </a:p>
@@ -14795,7 +14795,7 @@
                 <a:ea typeface="Segoe UI" pitchFamily="34" charset="-122"/>
                 <a:cs typeface="Segoe UI" pitchFamily="34" charset="-120"/>
               </a:rPr>
-              <a:t>Chọn 1 hoặc kết hợp - phần A (~794M) không hoàn, không khấu trừ</a:t>
+              <a:t>Chia doanh thu T03/27-T03/29 (2 năm đầu) - sau đó chuyển cổ phần</a:t>
             </a:r>
             <a:endParaRPr lang="en-US" sz="2500" dirty="0"/>
           </a:p>
@@ -14851,17 +14851,17 @@
                 <a:gridCol w="3657600"/>
                 <a:gridCol w="3657600"/>
               </a:tblGrid>
-              <a:tr h="566928">
-                <a:tc>
-                  <a:txBody>
-                    <a:bodyPr/>
-                    <a:lstStyle/>
-                    <a:p>
-                      <a:pPr indent="0" marL="0">
-                        <a:buNone/>
-                      </a:pPr>
-                      <a:r>
-                        <a:rPr lang="en-US" sz="1150" b="1" dirty="0">
+              <a:tr h="502920">
+                <a:tc>
+                  <a:txBody>
+                    <a:bodyPr/>
+                    <a:lstStyle/>
+                    <a:p>
+                      <a:pPr indent="0" marL="0">
+                        <a:buNone/>
+                      </a:pPr>
+                      <a:r>
+                        <a:rPr lang="en-US" sz="1100" b="1" dirty="0">
                           <a:solidFill>
                             <a:srgbClr val="FFFFFF"/>
                           </a:solidFill>
@@ -14871,7 +14871,7 @@
                         </a:rPr>
                         <a:t>Tiêu chí</a:t>
                       </a:r>
-                      <a:endParaRPr lang="en-US" sz="1150" dirty="0">
+                      <a:endParaRPr lang="en-US" sz="1100" dirty="0">
                         <a:latin typeface="Segoe UI" charset="0"/>
                         <a:ea typeface="Segoe UI" charset="0"/>
                         <a:cs typeface="Segoe UI" charset="0"/>
@@ -14929,7 +14929,7 @@
                         <a:buNone/>
                       </a:pPr>
                       <a:r>
-                        <a:rPr lang="en-US" sz="1150" b="1" dirty="0">
+                        <a:rPr lang="en-US" sz="1100" b="1" dirty="0">
                           <a:solidFill>
                             <a:srgbClr val="FFFFFF"/>
                           </a:solidFill>
@@ -14937,9 +14937,9 @@
                           <a:ea typeface="Segoe UI" pitchFamily="34" charset="-122"/>
                           <a:cs typeface="Segoe UI" pitchFamily="34" charset="-120"/>
                         </a:rPr>
-                        <a:t>PA-1: Đồng đầu tư theo tỷ lệ</a:t>
-                      </a:r>
-                      <a:endParaRPr lang="en-US" sz="1150" dirty="0">
+                        <a:t>PA-1: fund phần B (ưu tiên)</a:t>
+                      </a:r>
+                      <a:endParaRPr lang="en-US" sz="1100" dirty="0">
                         <a:latin typeface="Segoe UI" charset="0"/>
                         <a:ea typeface="Segoe UI" charset="0"/>
                         <a:cs typeface="Segoe UI" charset="0"/>
@@ -14997,7 +14997,7 @@
                         <a:buNone/>
                       </a:pPr>
                       <a:r>
-                        <a:rPr lang="en-US" sz="1150" b="1" dirty="0">
+                        <a:rPr lang="en-US" sz="1100" b="1" dirty="0">
                           <a:solidFill>
                             <a:srgbClr val="FFFFFF"/>
                           </a:solidFill>
@@ -15005,9 +15005,9 @@
                           <a:ea typeface="Segoe UI" pitchFamily="34" charset="-122"/>
                           <a:cs typeface="Segoe UI" pitchFamily="34" charset="-120"/>
                         </a:rPr>
-                        <a:t>PA-2: Recoupable advance</a:t>
-                      </a:r>
-                      <a:endParaRPr lang="en-US" sz="1150" dirty="0">
+                        <a:t>PA-2: fund B + C</a:t>
+                      </a:r>
+                      <a:endParaRPr lang="en-US" sz="1100" dirty="0">
                         <a:latin typeface="Segoe UI" charset="0"/>
                         <a:ea typeface="Segoe UI" charset="0"/>
                         <a:cs typeface="Segoe UI" charset="0"/>
@@ -15057,17 +15057,17 @@
                   </a:tcPr>
                 </a:tc>
               </a:tr>
-              <a:tr h="566928">
-                <a:tc>
-                  <a:txBody>
-                    <a:bodyPr/>
-                    <a:lstStyle/>
-                    <a:p>
-                      <a:pPr indent="0" marL="0">
-                        <a:buNone/>
-                      </a:pPr>
-                      <a:r>
-                        <a:rPr lang="en-US" sz="1150" dirty="0">
+              <a:tr h="502920">
+                <a:tc>
+                  <a:txBody>
+                    <a:bodyPr/>
+                    <a:lstStyle/>
+                    <a:p>
+                      <a:pPr indent="0" marL="0">
+                        <a:buNone/>
+                      </a:pPr>
+                      <a:r>
+                        <a:rPr lang="en-US" sz="1100" dirty="0">
                           <a:solidFill>
                             <a:srgbClr val="0F172A"/>
                           </a:solidFill>
@@ -15077,7 +15077,7 @@
                         </a:rPr>
                         <a:t>Nhà đầu tư bỏ ra</a:t>
                       </a:r>
-                      <a:endParaRPr lang="en-US" sz="1150" dirty="0">
+                      <a:endParaRPr lang="en-US" sz="1100" dirty="0">
                         <a:latin typeface="Segoe UI" charset="0"/>
                         <a:ea typeface="Segoe UI" charset="0"/>
                         <a:cs typeface="Segoe UI" charset="0"/>
@@ -15135,7 +15135,7 @@
                         <a:buNone/>
                       </a:pPr>
                       <a:r>
-                        <a:rPr lang="en-US" sz="1150" dirty="0">
+                        <a:rPr lang="en-US" sz="1100" dirty="0">
                           <a:solidFill>
                             <a:srgbClr val="0F172A"/>
                           </a:solidFill>
@@ -15143,9 +15143,9 @@
                           <a:ea typeface="Segoe UI" pitchFamily="34" charset="-122"/>
                           <a:cs typeface="Segoe UI" pitchFamily="34" charset="-120"/>
                         </a:rPr>
-                        <a:t>X% của B+C (~1 995M)</a:t>
-                      </a:r>
-                      <a:endParaRPr lang="en-US" sz="1150" dirty="0">
+                        <a:t>~829M (5.5 tháng phát triển)</a:t>
+                      </a:r>
+                      <a:endParaRPr lang="en-US" sz="1100" dirty="0">
                         <a:latin typeface="Segoe UI" charset="0"/>
                         <a:ea typeface="Segoe UI" charset="0"/>
                         <a:cs typeface="Segoe UI" charset="0"/>
@@ -15203,7 +15203,7 @@
                         <a:buNone/>
                       </a:pPr>
                       <a:r>
-                        <a:rPr lang="en-US" sz="1150" dirty="0">
+                        <a:rPr lang="en-US" sz="1100" dirty="0">
                           <a:solidFill>
                             <a:srgbClr val="0F172A"/>
                           </a:solidFill>
@@ -15211,9 +15211,9 @@
                           <a:ea typeface="Segoe UI" pitchFamily="34" charset="-122"/>
                           <a:cs typeface="Segoe UI" pitchFamily="34" charset="-120"/>
                         </a:rPr>
-                        <a:t>Ứng toàn bộ B (~829M) + C trả theo tháng (~55.5M)</a:t>
-                      </a:r>
-                      <a:endParaRPr lang="en-US" sz="1150" dirty="0">
+                        <a:t>~1 995M (B ứng trước + C theo tháng)</a:t>
+                      </a:r>
+                      <a:endParaRPr lang="en-US" sz="1100" dirty="0">
                         <a:latin typeface="Segoe UI" charset="0"/>
                         <a:ea typeface="Segoe UI" charset="0"/>
                         <a:cs typeface="Segoe UI" charset="0"/>
@@ -15263,17 +15263,17 @@
                   </a:tcPr>
                 </a:tc>
               </a:tr>
-              <a:tr h="566928">
-                <a:tc>
-                  <a:txBody>
-                    <a:bodyPr/>
-                    <a:lstStyle/>
-                    <a:p>
-                      <a:pPr indent="0" marL="0">
-                        <a:buNone/>
-                      </a:pPr>
-                      <a:r>
-                        <a:rPr lang="en-US" sz="1150" dirty="0">
+              <a:tr h="502920">
+                <a:tc>
+                  <a:txBody>
+                    <a:bodyPr/>
+                    <a:lstStyle/>
+                    <a:p>
+                      <a:pPr indent="0" marL="0">
+                        <a:buNone/>
+                      </a:pPr>
+                      <a:r>
+                        <a:rPr lang="en-US" sz="1100" dirty="0">
                           <a:solidFill>
                             <a:srgbClr val="0F172A"/>
                           </a:solidFill>
@@ -15281,9 +15281,9 @@
                           <a:ea typeface="Segoe UI" pitchFamily="34" charset="-122"/>
                           <a:cs typeface="Segoe UI" pitchFamily="34" charset="-120"/>
                         </a:rPr>
-                        <a:t>Bên phát triển gánh</a:t>
-                      </a:r>
-                      <a:endParaRPr lang="en-US" sz="1150" dirty="0">
+                        <a:t>Dev gánh</a:t>
+                      </a:r>
+                      <a:endParaRPr lang="en-US" sz="1100" dirty="0">
                         <a:latin typeface="Segoe UI" charset="0"/>
                         <a:ea typeface="Segoe UI" charset="0"/>
                         <a:cs typeface="Segoe UI" charset="0"/>
@@ -15341,7 +15341,7 @@
                         <a:buNone/>
                       </a:pPr>
                       <a:r>
-                        <a:rPr lang="en-US" sz="1150" dirty="0">
+                        <a:rPr lang="en-US" sz="1100" dirty="0">
                           <a:solidFill>
                             <a:srgbClr val="0F172A"/>
                           </a:solidFill>
@@ -15349,9 +15349,9 @@
                           <a:ea typeface="Segoe UI" pitchFamily="34" charset="-122"/>
                           <a:cs typeface="Segoe UI" pitchFamily="34" charset="-120"/>
                         </a:rPr>
-                        <a:t>Phần A sunk + (100-X)% của B+C</a:t>
-                      </a:r>
-                      <a:endParaRPr lang="en-US" sz="1150" dirty="0">
+                        <a:t>A sunk ~794M + tự gánh C ~1 166M + vận hành</a:t>
+                      </a:r>
+                      <a:endParaRPr lang="en-US" sz="1100" dirty="0">
                         <a:latin typeface="Segoe UI" charset="0"/>
                         <a:ea typeface="Segoe UI" charset="0"/>
                         <a:cs typeface="Segoe UI" charset="0"/>
@@ -15409,7 +15409,7 @@
                         <a:buNone/>
                       </a:pPr>
                       <a:r>
-                        <a:rPr lang="en-US" sz="1150" dirty="0">
+                        <a:rPr lang="en-US" sz="1100" dirty="0">
                           <a:solidFill>
                             <a:srgbClr val="0F172A"/>
                           </a:solidFill>
@@ -15417,9 +15417,9 @@
                           <a:ea typeface="Segoe UI" pitchFamily="34" charset="-122"/>
                           <a:cs typeface="Segoe UI" pitchFamily="34" charset="-120"/>
                         </a:rPr>
-                        <a:t>Phần A sunk; advance khấu trừ từ share khi có doanh thu</a:t>
-                      </a:r>
-                      <a:endParaRPr lang="en-US" sz="1150" dirty="0">
+                        <a:t>A sunk ~794M + vận hành</a:t>
+                      </a:r>
+                      <a:endParaRPr lang="en-US" sz="1100" dirty="0">
                         <a:latin typeface="Segoe UI" charset="0"/>
                         <a:ea typeface="Segoe UI" charset="0"/>
                         <a:cs typeface="Segoe UI" charset="0"/>
@@ -15469,17 +15469,17 @@
                   </a:tcPr>
                 </a:tc>
               </a:tr>
-              <a:tr h="566928">
-                <a:tc>
-                  <a:txBody>
-                    <a:bodyPr/>
-                    <a:lstStyle/>
-                    <a:p>
-                      <a:pPr indent="0" marL="0">
-                        <a:buNone/>
-                      </a:pPr>
-                      <a:r>
-                        <a:rPr lang="en-US" sz="1150" dirty="0">
+              <a:tr h="502920">
+                <a:tc>
+                  <a:txBody>
+                    <a:bodyPr/>
+                    <a:lstStyle/>
+                    <a:p>
+                      <a:pPr indent="0" marL="0">
+                        <a:buNone/>
+                      </a:pPr>
+                      <a:r>
+                        <a:rPr lang="en-US" sz="1100" dirty="0">
                           <a:solidFill>
                             <a:srgbClr val="0F172A"/>
                           </a:solidFill>
@@ -15487,9 +15487,9 @@
                           <a:ea typeface="Segoe UI" pitchFamily="34" charset="-122"/>
                           <a:cs typeface="Segoe UI" pitchFamily="34" charset="-120"/>
                         </a:rPr>
-                        <a:t>Rủi ro nhà đầu tư</a:t>
-                      </a:r>
-                      <a:endParaRPr lang="en-US" sz="1150" dirty="0">
+                        <a:t>Rev-share T03/27-T03/29</a:t>
+                      </a:r>
+                      <a:endParaRPr lang="en-US" sz="1100" dirty="0">
                         <a:latin typeface="Segoe UI" charset="0"/>
                         <a:ea typeface="Segoe UI" charset="0"/>
                         <a:cs typeface="Segoe UI" charset="0"/>
@@ -15547,7 +15547,7 @@
                         <a:buNone/>
                       </a:pPr>
                       <a:r>
-                        <a:rPr lang="en-US" sz="1150" dirty="0">
+                        <a:rPr lang="en-US" sz="1100" dirty="0">
                           <a:solidFill>
                             <a:srgbClr val="0F172A"/>
                           </a:solidFill>
@@ -15555,9 +15555,9 @@
                           <a:ea typeface="Segoe UI" pitchFamily="34" charset="-122"/>
                           <a:cs typeface="Segoe UI" pitchFamily="34" charset="-120"/>
                         </a:rPr>
-                        <a:t>Mất tối đa phần đã bỏ nếu dự án dừng</a:t>
-                      </a:r>
-                      <a:endParaRPr lang="en-US" sz="1150" dirty="0">
+                        <a:t>Nhà đầu tư 40-45% / dev 55-60%</a:t>
+                      </a:r>
+                      <a:endParaRPr lang="en-US" sz="1100" dirty="0">
                         <a:latin typeface="Segoe UI" charset="0"/>
                         <a:ea typeface="Segoe UI" charset="0"/>
                         <a:cs typeface="Segoe UI" charset="0"/>
@@ -15615,7 +15615,7 @@
                         <a:buNone/>
                       </a:pPr>
                       <a:r>
-                        <a:rPr lang="en-US" sz="1150" dirty="0">
+                        <a:rPr lang="en-US" sz="1100" dirty="0">
                           <a:solidFill>
                             <a:srgbClr val="0F172A"/>
                           </a:solidFill>
@@ -15623,9 +15623,9 @@
                           <a:ea typeface="Segoe UI" pitchFamily="34" charset="-122"/>
                           <a:cs typeface="Segoe UI" pitchFamily="34" charset="-120"/>
                         </a:rPr>
-                        <a:t>Advance chỉ thu hồi khi có doanh thu - rủi ro timing, không mất vốn nếu thành công</a:t>
-                      </a:r>
-                      <a:endParaRPr lang="en-US" sz="1150" dirty="0">
+                        <a:t>Nhà đầu tư 60-65% / dev 35-40%</a:t>
+                      </a:r>
+                      <a:endParaRPr lang="en-US" sz="1100" dirty="0">
                         <a:latin typeface="Segoe UI" charset="0"/>
                         <a:ea typeface="Segoe UI" charset="0"/>
                         <a:cs typeface="Segoe UI" charset="0"/>
@@ -15675,17 +15675,17 @@
                   </a:tcPr>
                 </a:tc>
               </a:tr>
-              <a:tr h="566928">
-                <a:tc>
-                  <a:txBody>
-                    <a:bodyPr/>
-                    <a:lstStyle/>
-                    <a:p>
-                      <a:pPr indent="0" marL="0">
-                        <a:buNone/>
-                      </a:pPr>
-                      <a:r>
-                        <a:rPr lang="en-US" sz="1150" dirty="0">
+              <a:tr h="502920">
+                <a:tc>
+                  <a:txBody>
+                    <a:bodyPr/>
+                    <a:lstStyle/>
+                    <a:p>
+                      <a:pPr indent="0" marL="0">
+                        <a:buNone/>
+                      </a:pPr>
+                      <a:r>
+                        <a:rPr lang="en-US" sz="1100" dirty="0">
                           <a:solidFill>
                             <a:srgbClr val="0F172A"/>
                           </a:solidFill>
@@ -15693,9 +15693,9 @@
                           <a:ea typeface="Segoe UI" pitchFamily="34" charset="-122"/>
                           <a:cs typeface="Segoe UI" pitchFamily="34" charset="-120"/>
                         </a:rPr>
-                        <a:t>Phù hợp khi</a:t>
-                      </a:r>
-                      <a:endParaRPr lang="en-US" sz="1150" dirty="0">
+                        <a:t>Recoup-first</a:t>
+                      </a:r>
+                      <a:endParaRPr lang="en-US" sz="1100" dirty="0">
                         <a:latin typeface="Segoe UI" charset="0"/>
                         <a:ea typeface="Segoe UI" charset="0"/>
                         <a:cs typeface="Segoe UI" charset="0"/>
@@ -15753,7 +15753,7 @@
                         <a:buNone/>
                       </a:pPr>
                       <a:r>
-                        <a:rPr lang="en-US" sz="1150" dirty="0">
+                        <a:rPr lang="en-US" sz="1100" dirty="0">
                           <a:solidFill>
                             <a:srgbClr val="0F172A"/>
                           </a:solidFill>
@@ -15761,9 +15761,9 @@
                           <a:ea typeface="Segoe UI" pitchFamily="34" charset="-122"/>
                           <a:cs typeface="Segoe UI" pitchFamily="34" charset="-120"/>
                         </a:rPr>
-                        <a:t>Muốn rủi ro thấp + chia upside dài hạn</a:t>
-                      </a:r>
-                      <a:endParaRPr lang="en-US" sz="1150" dirty="0">
+                        <a:t>Share NĐT trừ gốc 829M; recoup xong còn ~30-35%</a:t>
+                      </a:r>
+                      <a:endParaRPr lang="en-US" sz="1100" dirty="0">
                         <a:latin typeface="Segoe UI" charset="0"/>
                         <a:ea typeface="Segoe UI" charset="0"/>
                         <a:cs typeface="Segoe UI" charset="0"/>
@@ -15821,7 +15821,7 @@
                         <a:buNone/>
                       </a:pPr>
                       <a:r>
-                        <a:rPr lang="en-US" sz="1150" dirty="0">
+                        <a:rPr lang="en-US" sz="1100" dirty="0">
                           <a:solidFill>
                             <a:srgbClr val="0F172A"/>
                           </a:solidFill>
@@ -15829,9 +15829,9 @@
                           <a:ea typeface="Segoe UI" pitchFamily="34" charset="-122"/>
                           <a:cs typeface="Segoe UI" pitchFamily="34" charset="-120"/>
                         </a:rPr>
-                        <a:t>Tin sản phẩm, muốn cơ chế hoàn vốn rõ ràng</a:t>
-                      </a:r>
-                      <a:endParaRPr lang="en-US" sz="1150" dirty="0">
+                        <a:t>Trừ trên tổng giải ngân; recoup xong còn ~40-45%</a:t>
+                      </a:r>
+                      <a:endParaRPr lang="en-US" sz="1100" dirty="0">
                         <a:latin typeface="Segoe UI" charset="0"/>
                         <a:ea typeface="Segoe UI" charset="0"/>
                         <a:cs typeface="Segoe UI" charset="0"/>
@@ -15877,6 +15877,212 @@
                     </a:lnB>
                     <a:solidFill>
                       <a:srgbClr val="F8FAFC"/>
+                    </a:solidFill>
+                  </a:tcPr>
+                </a:tc>
+              </a:tr>
+              <a:tr h="502920">
+                <a:tc>
+                  <a:txBody>
+                    <a:bodyPr/>
+                    <a:lstStyle/>
+                    <a:p>
+                      <a:pPr indent="0" marL="0">
+                        <a:buNone/>
+                      </a:pPr>
+                      <a:r>
+                        <a:rPr lang="en-US" sz="1100" dirty="0">
+                          <a:solidFill>
+                            <a:srgbClr val="0F172A"/>
+                          </a:solidFill>
+                          <a:latin typeface="Segoe UI" pitchFamily="34" charset="0"/>
+                          <a:ea typeface="Segoe UI" pitchFamily="34" charset="-122"/>
+                          <a:cs typeface="Segoe UI" pitchFamily="34" charset="-120"/>
+                        </a:rPr>
+                        <a:t>Cổ phần sau T03/2029</a:t>
+                      </a:r>
+                      <a:endParaRPr lang="en-US" sz="1100" dirty="0">
+                        <a:latin typeface="Segoe UI" charset="0"/>
+                        <a:ea typeface="Segoe UI" charset="0"/>
+                        <a:cs typeface="Segoe UI" charset="0"/>
+                      </a:endParaRPr>
+                    </a:p>
+                  </a:txBody>
+                  <a:tcPr marL="54864" marR="54864" marT="54864" marB="54864" anchor="ctr">
+                    <a:lnL w="9525" cap="flat" cmpd="sng" algn="ctr">
+                      <a:solidFill>
+                        <a:srgbClr val="E2E8F0"/>
+                      </a:solidFill>
+                      <a:prstDash val="solid"/>
+                      <a:round/>
+                      <a:headEnd type="none" w="med" len="med"/>
+                      <a:tailEnd type="none" w="med" len="med"/>
+                    </a:lnL>
+                    <a:lnR w="9525" cap="flat" cmpd="sng" algn="ctr">
+                      <a:solidFill>
+                        <a:srgbClr val="E2E8F0"/>
+                      </a:solidFill>
+                      <a:prstDash val="solid"/>
+                      <a:round/>
+                      <a:headEnd type="none" w="med" len="med"/>
+                      <a:tailEnd type="none" w="med" len="med"/>
+                    </a:lnR>
+                    <a:lnT w="9525" cap="flat" cmpd="sng" algn="ctr">
+                      <a:solidFill>
+                        <a:srgbClr val="E2E8F0"/>
+                      </a:solidFill>
+                      <a:prstDash val="solid"/>
+                      <a:round/>
+                      <a:headEnd type="none" w="med" len="med"/>
+                      <a:tailEnd type="none" w="med" len="med"/>
+                    </a:lnT>
+                    <a:lnB w="9525" cap="flat" cmpd="sng" algn="ctr">
+                      <a:solidFill>
+                        <a:srgbClr val="E2E8F0"/>
+                      </a:solidFill>
+                      <a:prstDash val="solid"/>
+                      <a:round/>
+                      <a:headEnd type="none" w="med" len="med"/>
+                      <a:tailEnd type="none" w="med" len="med"/>
+                    </a:lnB>
+                    <a:solidFill>
+                      <a:srgbClr val="FFFFFF"/>
+                    </a:solidFill>
+                  </a:tcPr>
+                </a:tc>
+                <a:tc>
+                  <a:txBody>
+                    <a:bodyPr/>
+                    <a:lstStyle/>
+                    <a:p>
+                      <a:pPr indent="0" marL="0">
+                        <a:buNone/>
+                      </a:pPr>
+                      <a:r>
+                        <a:rPr lang="en-US" sz="1100" dirty="0">
+                          <a:solidFill>
+                            <a:srgbClr val="0F172A"/>
+                          </a:solidFill>
+                          <a:latin typeface="Segoe UI" pitchFamily="34" charset="0"/>
+                          <a:ea typeface="Segoe UI" pitchFamily="34" charset="-122"/>
+                          <a:cs typeface="Segoe UI" pitchFamily="34" charset="-120"/>
+                        </a:rPr>
+                        <a:t>~10-15%</a:t>
+                      </a:r>
+                      <a:endParaRPr lang="en-US" sz="1100" dirty="0">
+                        <a:latin typeface="Segoe UI" charset="0"/>
+                        <a:ea typeface="Segoe UI" charset="0"/>
+                        <a:cs typeface="Segoe UI" charset="0"/>
+                      </a:endParaRPr>
+                    </a:p>
+                  </a:txBody>
+                  <a:tcPr marL="54864" marR="54864" marT="54864" marB="54864" anchor="ctr">
+                    <a:lnL w="9525" cap="flat" cmpd="sng" algn="ctr">
+                      <a:solidFill>
+                        <a:srgbClr val="E2E8F0"/>
+                      </a:solidFill>
+                      <a:prstDash val="solid"/>
+                      <a:round/>
+                      <a:headEnd type="none" w="med" len="med"/>
+                      <a:tailEnd type="none" w="med" len="med"/>
+                    </a:lnL>
+                    <a:lnR w="9525" cap="flat" cmpd="sng" algn="ctr">
+                      <a:solidFill>
+                        <a:srgbClr val="E2E8F0"/>
+                      </a:solidFill>
+                      <a:prstDash val="solid"/>
+                      <a:round/>
+                      <a:headEnd type="none" w="med" len="med"/>
+                      <a:tailEnd type="none" w="med" len="med"/>
+                    </a:lnR>
+                    <a:lnT w="9525" cap="flat" cmpd="sng" algn="ctr">
+                      <a:solidFill>
+                        <a:srgbClr val="E2E8F0"/>
+                      </a:solidFill>
+                      <a:prstDash val="solid"/>
+                      <a:round/>
+                      <a:headEnd type="none" w="med" len="med"/>
+                      <a:tailEnd type="none" w="med" len="med"/>
+                    </a:lnT>
+                    <a:lnB w="9525" cap="flat" cmpd="sng" algn="ctr">
+                      <a:solidFill>
+                        <a:srgbClr val="E2E8F0"/>
+                      </a:solidFill>
+                      <a:prstDash val="solid"/>
+                      <a:round/>
+                      <a:headEnd type="none" w="med" len="med"/>
+                      <a:tailEnd type="none" w="med" len="med"/>
+                    </a:lnB>
+                    <a:solidFill>
+                      <a:srgbClr val="FFFFFF"/>
+                    </a:solidFill>
+                  </a:tcPr>
+                </a:tc>
+                <a:tc>
+                  <a:txBody>
+                    <a:bodyPr/>
+                    <a:lstStyle/>
+                    <a:p>
+                      <a:pPr indent="0" marL="0">
+                        <a:buNone/>
+                      </a:pPr>
+                      <a:r>
+                        <a:rPr lang="en-US" sz="1100" dirty="0">
+                          <a:solidFill>
+                            <a:srgbClr val="0F172A"/>
+                          </a:solidFill>
+                          <a:latin typeface="Segoe UI" pitchFamily="34" charset="0"/>
+                          <a:ea typeface="Segoe UI" pitchFamily="34" charset="-122"/>
+                          <a:cs typeface="Segoe UI" pitchFamily="34" charset="-120"/>
+                        </a:rPr>
+                        <a:t>~20-25%</a:t>
+                      </a:r>
+                      <a:endParaRPr lang="en-US" sz="1100" dirty="0">
+                        <a:latin typeface="Segoe UI" charset="0"/>
+                        <a:ea typeface="Segoe UI" charset="0"/>
+                        <a:cs typeface="Segoe UI" charset="0"/>
+                      </a:endParaRPr>
+                    </a:p>
+                  </a:txBody>
+                  <a:tcPr marL="54864" marR="54864" marT="54864" marB="54864" anchor="ctr">
+                    <a:lnL w="9525" cap="flat" cmpd="sng" algn="ctr">
+                      <a:solidFill>
+                        <a:srgbClr val="E2E8F0"/>
+                      </a:solidFill>
+                      <a:prstDash val="solid"/>
+                      <a:round/>
+                      <a:headEnd type="none" w="med" len="med"/>
+                      <a:tailEnd type="none" w="med" len="med"/>
+                    </a:lnL>
+                    <a:lnR w="9525" cap="flat" cmpd="sng" algn="ctr">
+                      <a:solidFill>
+                        <a:srgbClr val="E2E8F0"/>
+                      </a:solidFill>
+                      <a:prstDash val="solid"/>
+                      <a:round/>
+                      <a:headEnd type="none" w="med" len="med"/>
+                      <a:tailEnd type="none" w="med" len="med"/>
+                    </a:lnR>
+                    <a:lnT w="9525" cap="flat" cmpd="sng" algn="ctr">
+                      <a:solidFill>
+                        <a:srgbClr val="E2E8F0"/>
+                      </a:solidFill>
+                      <a:prstDash val="solid"/>
+                      <a:round/>
+                      <a:headEnd type="none" w="med" len="med"/>
+                      <a:tailEnd type="none" w="med" len="med"/>
+                    </a:lnT>
+                    <a:lnB w="9525" cap="flat" cmpd="sng" algn="ctr">
+                      <a:solidFill>
+                        <a:srgbClr val="E2E8F0"/>
+                      </a:solidFill>
+                      <a:prstDash val="solid"/>
+                      <a:round/>
+                      <a:headEnd type="none" w="med" len="med"/>
+                      <a:tailEnd type="none" w="med" len="med"/>
+                    </a:lnB>
+                    <a:solidFill>
+                      <a:srgbClr val="FFFFFF"/>
                     </a:solidFill>
                   </a:tcPr>
                 </a:tc>
@@ -15893,7 +16099,7 @@
         </p:nvSpPr>
         <p:spPr>
           <a:xfrm>
-            <a:off x="640080" y="5760720"/>
+            <a:off x="640080" y="5897880"/>
             <a:ext cx="10972800" cy="411480"/>
           </a:xfrm>
           <a:prstGeom prst="rect">
@@ -15918,7 +16124,7 @@
                 <a:ea typeface="Segoe UI" pitchFamily="34" charset="-122"/>
                 <a:cs typeface="Segoe UI" pitchFamily="34" charset="-120"/>
               </a:rPr>
-              <a:t>PA-2 là chuẩn 'recoupable advance against royalty' trong licensing/publishing tech - không clawback tiền mặt, chỉ trừ từ phần share tương lai.</a:t>
+              <a:t>Nhà đầu tư được share cao hơn tỷ lệ vốn đóng góp (bù rủi ro early); dev giữ majority/IP vì gánh sunk A + maintain + vận hành.</a:t>
             </a:r>
             <a:endParaRPr lang="en-US" sz="1050" dirty="0"/>
           </a:p>
@@ -16086,7 +16292,7 @@
                         <a:buNone/>
                       </a:pPr>
                       <a:r>
-                        <a:rPr lang="en-US" sz="1150" b="1" dirty="0">
+                        <a:rPr lang="en-US" sz="1100" b="1" dirty="0">
                           <a:solidFill>
                             <a:srgbClr val="FFFFFF"/>
                           </a:solidFill>
@@ -16096,7 +16302,7 @@
                         </a:rPr>
                         <a:t>Mục</a:t>
                       </a:r>
-                      <a:endParaRPr lang="en-US" sz="1150" dirty="0">
+                      <a:endParaRPr lang="en-US" sz="1100" dirty="0">
                         <a:latin typeface="Segoe UI" charset="0"/>
                         <a:ea typeface="Segoe UI" charset="0"/>
                         <a:cs typeface="Segoe UI" charset="0"/>
@@ -16154,7 +16360,7 @@
                         <a:buNone/>
                       </a:pPr>
                       <a:r>
-                        <a:rPr lang="en-US" sz="1150" b="1" dirty="0">
+                        <a:rPr lang="en-US" sz="1100" b="1" dirty="0">
                           <a:solidFill>
                             <a:srgbClr val="FFFFFF"/>
                           </a:solidFill>
@@ -16164,7 +16370,7 @@
                         </a:rPr>
                         <a:t>Giá trị</a:t>
                       </a:r>
-                      <a:endParaRPr lang="en-US" sz="1150" dirty="0">
+                      <a:endParaRPr lang="en-US" sz="1100" dirty="0">
                         <a:latin typeface="Segoe UI" charset="0"/>
                         <a:ea typeface="Segoe UI" charset="0"/>
                         <a:cs typeface="Segoe UI" charset="0"/>
@@ -16224,7 +16430,7 @@
                         <a:buNone/>
                       </a:pPr>
                       <a:r>
-                        <a:rPr lang="en-US" sz="1150" dirty="0">
+                        <a:rPr lang="en-US" sz="1100" dirty="0">
                           <a:solidFill>
                             <a:srgbClr val="0F172A"/>
                           </a:solidFill>
@@ -16234,7 +16440,7 @@
                         </a:rPr>
                         <a:t>Tổng kinh phí dự án</a:t>
                       </a:r>
-                      <a:endParaRPr lang="en-US" sz="1150" dirty="0">
+                      <a:endParaRPr lang="en-US" sz="1100" dirty="0">
                         <a:latin typeface="Segoe UI" charset="0"/>
                         <a:ea typeface="Segoe UI" charset="0"/>
                         <a:cs typeface="Segoe UI" charset="0"/>
@@ -16292,7 +16498,7 @@
                         <a:buNone/>
                       </a:pPr>
                       <a:r>
-                        <a:rPr lang="en-US" sz="1150" dirty="0">
+                        <a:rPr lang="en-US" sz="1100" dirty="0">
                           <a:solidFill>
                             <a:srgbClr val="0F172A"/>
                           </a:solidFill>
@@ -16302,7 +16508,7 @@
                         </a:rPr>
                         <a:t>~2 788 650 000 VND (~2.79 tỷ)</a:t>
                       </a:r>
-                      <a:endParaRPr lang="en-US" sz="1150" dirty="0">
+                      <a:endParaRPr lang="en-US" sz="1100" dirty="0">
                         <a:latin typeface="Segoe UI" charset="0"/>
                         <a:ea typeface="Segoe UI" charset="0"/>
                         <a:cs typeface="Segoe UI" charset="0"/>
@@ -16362,7 +16568,7 @@
                         <a:buNone/>
                       </a:pPr>
                       <a:r>
-                        <a:rPr lang="en-US" sz="1150" dirty="0">
+                        <a:rPr lang="en-US" sz="1100" dirty="0">
                           <a:solidFill>
                             <a:srgbClr val="0F172A"/>
                           </a:solidFill>
@@ -16372,7 +16578,7 @@
                         </a:rPr>
                         <a:t>Đã đầu tư (sunk - sweat equity)</a:t>
                       </a:r>
-                      <a:endParaRPr lang="en-US" sz="1150" dirty="0">
+                      <a:endParaRPr lang="en-US" sz="1100" dirty="0">
                         <a:latin typeface="Segoe UI" charset="0"/>
                         <a:ea typeface="Segoe UI" charset="0"/>
                         <a:cs typeface="Segoe UI" charset="0"/>
@@ -16430,7 +16636,7 @@
                         <a:buNone/>
                       </a:pPr>
                       <a:r>
-                        <a:rPr lang="en-US" sz="1150" dirty="0">
+                        <a:rPr lang="en-US" sz="1100" dirty="0">
                           <a:solidFill>
                             <a:srgbClr val="0F172A"/>
                           </a:solidFill>
@@ -16440,7 +16646,7 @@
                         </a:rPr>
                         <a:t>~793.7M (28%) - T03/26 → 15/10/26</a:t>
                       </a:r>
-                      <a:endParaRPr lang="en-US" sz="1150" dirty="0">
+                      <a:endParaRPr lang="en-US" sz="1100" dirty="0">
                         <a:latin typeface="Segoe UI" charset="0"/>
                         <a:ea typeface="Segoe UI" charset="0"/>
                         <a:cs typeface="Segoe UI" charset="0"/>
@@ -16500,7 +16706,7 @@
                         <a:buNone/>
                       </a:pPr>
                       <a:r>
-                        <a:rPr lang="en-US" sz="1150" dirty="0">
+                        <a:rPr lang="en-US" sz="1100" dirty="0">
                           <a:solidFill>
                             <a:srgbClr val="0F172A"/>
                           </a:solidFill>
@@ -16508,9 +16714,9 @@
                           <a:ea typeface="Segoe UI" pitchFamily="34" charset="-122"/>
                           <a:cs typeface="Segoe UI" pitchFamily="34" charset="-120"/>
                         </a:rPr>
-                        <a:t>Cần đồng đầu tư (B + C)</a:t>
-                      </a:r>
-                      <a:endParaRPr lang="en-US" sz="1150" dirty="0">
+                        <a:t>PA-1 - kêu gọi trước tiên</a:t>
+                      </a:r>
+                      <a:endParaRPr lang="en-US" sz="1100" dirty="0">
                         <a:latin typeface="Segoe UI" charset="0"/>
                         <a:ea typeface="Segoe UI" charset="0"/>
                         <a:cs typeface="Segoe UI" charset="0"/>
@@ -16568,7 +16774,7 @@
                         <a:buNone/>
                       </a:pPr>
                       <a:r>
-                        <a:rPr lang="en-US" sz="1150" dirty="0">
+                        <a:rPr lang="en-US" sz="1100" dirty="0">
                           <a:solidFill>
                             <a:srgbClr val="0F172A"/>
                           </a:solidFill>
@@ -16576,9 +16782,9 @@
                           <a:ea typeface="Segoe UI" pitchFamily="34" charset="-122"/>
                           <a:cs typeface="Segoe UI" pitchFamily="34" charset="-120"/>
                         </a:rPr>
-                        <a:t>~1 995M (72%)</a:t>
-                      </a:r>
-                      <a:endParaRPr lang="en-US" sz="1150" dirty="0">
+                        <a:t>Phần B ~829M → NĐT 40-45% rev-share 2 năm + ~10-15% cổ phần sau 2029</a:t>
+                      </a:r>
+                      <a:endParaRPr lang="en-US" sz="1100" dirty="0">
                         <a:latin typeface="Segoe UI" charset="0"/>
                         <a:ea typeface="Segoe UI" charset="0"/>
                         <a:cs typeface="Segoe UI" charset="0"/>
@@ -16638,7 +16844,7 @@
                         <a:buNone/>
                       </a:pPr>
                       <a:r>
-                        <a:rPr lang="en-US" sz="1150" dirty="0">
+                        <a:rPr lang="en-US" sz="1100" dirty="0">
                           <a:solidFill>
                             <a:srgbClr val="0F172A"/>
                           </a:solidFill>
@@ -16646,9 +16852,9 @@
                           <a:ea typeface="Segoe UI" pitchFamily="34" charset="-122"/>
                           <a:cs typeface="Segoe UI" pitchFamily="34" charset="-120"/>
                         </a:rPr>
-                        <a:t>Burn rate build phase</a:t>
-                      </a:r>
-                      <a:endParaRPr lang="en-US" sz="1150" dirty="0">
+                        <a:t>PA-2 - mở rộng</a:t>
+                      </a:r>
+                      <a:endParaRPr lang="en-US" sz="1100" dirty="0">
                         <a:latin typeface="Segoe UI" charset="0"/>
                         <a:ea typeface="Segoe UI" charset="0"/>
                         <a:cs typeface="Segoe UI" charset="0"/>
@@ -16706,7 +16912,7 @@
                         <a:buNone/>
                       </a:pPr>
                       <a:r>
-                        <a:rPr lang="en-US" sz="1150" dirty="0">
+                        <a:rPr lang="en-US" sz="1100" dirty="0">
                           <a:solidFill>
                             <a:srgbClr val="0F172A"/>
                           </a:solidFill>
@@ -16714,9 +16920,9 @@
                           <a:ea typeface="Segoe UI" pitchFamily="34" charset="-122"/>
                           <a:cs typeface="Segoe UI" pitchFamily="34" charset="-120"/>
                         </a:rPr>
-                        <a:t>129M nhân sự + ~8.1M infra /tháng × 5.5 tháng</a:t>
-                      </a:r>
-                      <a:endParaRPr lang="en-US" sz="1150" dirty="0">
+                        <a:t>B+C ~1 995M → NĐT 60-65% rev-share 2 năm + ~20-25% cổ phần sau 2029</a:t>
+                      </a:r>
+                      <a:endParaRPr lang="en-US" sz="1100" dirty="0">
                         <a:latin typeface="Segoe UI" charset="0"/>
                         <a:ea typeface="Segoe UI" charset="0"/>
                         <a:cs typeface="Segoe UI" charset="0"/>
@@ -16776,7 +16982,7 @@
                         <a:buNone/>
                       </a:pPr>
                       <a:r>
-                        <a:rPr lang="en-US" sz="1150" dirty="0">
+                        <a:rPr lang="en-US" sz="1100" dirty="0">
                           <a:solidFill>
                             <a:srgbClr val="0F172A"/>
                           </a:solidFill>
@@ -16784,9 +16990,9 @@
                           <a:ea typeface="Segoe UI" pitchFamily="34" charset="-122"/>
                           <a:cs typeface="Segoe UI" pitchFamily="34" charset="-120"/>
                         </a:rPr>
-                        <a:t>Burn rate maintain</a:t>
-                      </a:r>
-                      <a:endParaRPr lang="en-US" sz="1150" dirty="0">
+                        <a:t>Burn rate</a:t>
+                      </a:r>
+                      <a:endParaRPr lang="en-US" sz="1100" dirty="0">
                         <a:latin typeface="Segoe UI" charset="0"/>
                         <a:ea typeface="Segoe UI" charset="0"/>
                         <a:cs typeface="Segoe UI" charset="0"/>
@@ -16844,7 +17050,7 @@
                         <a:buNone/>
                       </a:pPr>
                       <a:r>
-                        <a:rPr lang="en-US" sz="1150" dirty="0">
+                        <a:rPr lang="en-US" sz="1100" dirty="0">
                           <a:solidFill>
                             <a:srgbClr val="0F172A"/>
                           </a:solidFill>
@@ -16852,9 +17058,9 @@
                           <a:ea typeface="Segoe UI" pitchFamily="34" charset="-122"/>
                           <a:cs typeface="Segoe UI" pitchFamily="34" charset="-120"/>
                         </a:rPr>
-                        <a:t>46.5M nhân sự + ~9M infra /tháng × 21 tháng</a:t>
-                      </a:r>
-                      <a:endParaRPr lang="en-US" sz="1150" dirty="0">
+                        <a:t>Build: 129M NS + ~8.1M infra /th · Maintain: 46.5M NS + ~9M infra /th</a:t>
+                      </a:r>
+                      <a:endParaRPr lang="en-US" sz="1100" dirty="0">
                         <a:latin typeface="Segoe UI" charset="0"/>
                         <a:ea typeface="Segoe UI" charset="0"/>
                         <a:cs typeface="Segoe UI" charset="0"/>
@@ -16914,7 +17120,7 @@
                         <a:buNone/>
                       </a:pPr>
                       <a:r>
-                        <a:rPr lang="en-US" sz="1150" dirty="0">
+                        <a:rPr lang="en-US" sz="1100" dirty="0">
                           <a:solidFill>
                             <a:srgbClr val="0F172A"/>
                           </a:solidFill>
@@ -16924,7 +17130,7 @@
                         </a:rPr>
                         <a:t>Trạng thái sản phẩm</a:t>
                       </a:r>
-                      <a:endParaRPr lang="en-US" sz="1150" dirty="0">
+                      <a:endParaRPr lang="en-US" sz="1100" dirty="0">
                         <a:latin typeface="Segoe UI" charset="0"/>
                         <a:ea typeface="Segoe UI" charset="0"/>
                         <a:cs typeface="Segoe UI" charset="0"/>
@@ -16982,7 +17188,7 @@
                         <a:buNone/>
                       </a:pPr>
                       <a:r>
-                        <a:rPr lang="en-US" sz="1150" dirty="0">
+                        <a:rPr lang="en-US" sz="1100" dirty="0">
                           <a:solidFill>
                             <a:srgbClr val="0F172A"/>
                           </a:solidFill>
@@ -16992,7 +17198,7 @@
                         </a:rPr>
                         <a:t>Live production - 3 trường demo - QA xanh - ~30 vòng external review</a:t>
                       </a:r>
-                      <a:endParaRPr lang="en-US" sz="1150" dirty="0">
+                      <a:endParaRPr lang="en-US" sz="1100" dirty="0">
                         <a:latin typeface="Segoe UI" charset="0"/>
                         <a:ea typeface="Segoe UI" charset="0"/>
                         <a:cs typeface="Segoe UI" charset="0"/>
@@ -17054,7 +17260,7 @@
         </p:nvSpPr>
         <p:spPr>
           <a:xfrm>
-            <a:off x="640080" y="4892040"/>
+            <a:off x="640080" y="4937760"/>
             <a:ext cx="10972800" cy="4572000"/>
           </a:xfrm>
           <a:prstGeom prst="rect">
@@ -17083,7 +17289,7 @@
                 <a:ea typeface="Segoe UI" pitchFamily="34" charset="-122"/>
                 <a:cs typeface="Segoe UI" pitchFamily="34" charset="-120"/>
               </a:rPr>
-              <a:t>Điều khoản bắt buộc: giải ngân theo milestone - phần A không hoàn/khấu trừ - báo cáo burn hàng tháng + audit rights - IP thuộc bên phát triển - clock doanh thu đếm từ khách paid đầu tiên - scale &gt;5 trường thì review hạ tầng qua CR riêng</a:t>
+              <a:t>Điều khoản bắt buộc: giải ngân theo milestone - phần A không hoàn/khấu trừ - clock doanh thu đếm từ khách paid đầu tiên (trễ thì dịch cửa sổ) - cổ phần vesting từ ngày ký - báo cáo burn hàng tháng + audit rights - IP thuộc bên phát triển - scale &gt;5 trường thì review hạ tầng qua CR riêng</a:t>
             </a:r>
             <a:endParaRPr lang="en-US" sz="1150" dirty="0"/>
           </a:p>

</xml_diff>

<commit_message>
docs: proposal - 50-50 chi phi (share-risk), NDT ~40-45% rev-share
PA-1: NDT ganh 50% B ~414.7M, NDT ~40% rev-share 2 nam + ~10-15% CP sau.
PA-2: NDT ganh 50% (B+C) ~997.5M, NDT ~45% rev-share + ~15-20% CP sau.

Generated with [Devin](https://devin.ai)

Co-Authored-By: Devin <158243242+devin-ai-integration[bot]@users.noreply.github.com>
</commit_message>
<xml_diff>
--- a/docs/handover/PROPOSAL-tong-dau-tu-2ty8.pptx
+++ b/docs/handover/PROPOSAL-tong-dau-tu-2ty8.pptx
@@ -15075,7 +15075,7 @@
                           <a:ea typeface="Segoe UI" pitchFamily="34" charset="-122"/>
                           <a:cs typeface="Segoe UI" pitchFamily="34" charset="-120"/>
                         </a:rPr>
-                        <a:t>Nhà đầu tư bỏ ra</a:t>
+                        <a:t>Nhà đầu tư gánh (50%)</a:t>
                       </a:r>
                       <a:endParaRPr lang="en-US" sz="1100" dirty="0">
                         <a:latin typeface="Segoe UI" charset="0"/>
@@ -15143,7 +15143,7 @@
                           <a:ea typeface="Segoe UI" pitchFamily="34" charset="-122"/>
                           <a:cs typeface="Segoe UI" pitchFamily="34" charset="-120"/>
                         </a:rPr>
-                        <a:t>~829M (5.5 tháng phát triển)</a:t>
+                        <a:t>~414 725 000 (50% phần B)</a:t>
                       </a:r>
                       <a:endParaRPr lang="en-US" sz="1100" dirty="0">
                         <a:latin typeface="Segoe UI" charset="0"/>
@@ -15211,7 +15211,7 @@
                           <a:ea typeface="Segoe UI" pitchFamily="34" charset="-122"/>
                           <a:cs typeface="Segoe UI" pitchFamily="34" charset="-120"/>
                         </a:rPr>
-                        <a:t>~1 995M (B ứng trước + C theo tháng)</a:t>
+                        <a:t>~997 475 000 (50% của B+C)</a:t>
                       </a:r>
                       <a:endParaRPr lang="en-US" sz="1100" dirty="0">
                         <a:latin typeface="Segoe UI" charset="0"/>
@@ -15349,7 +15349,7 @@
                           <a:ea typeface="Segoe UI" pitchFamily="34" charset="-122"/>
                           <a:cs typeface="Segoe UI" pitchFamily="34" charset="-120"/>
                         </a:rPr>
-                        <a:t>A sunk ~794M + tự gánh C ~1 166M + vận hành</a:t>
+                        <a:t>50% B + A sunk ~794M + tự gánh C ~1 166M + vận hành</a:t>
                       </a:r>
                       <a:endParaRPr lang="en-US" sz="1100" dirty="0">
                         <a:latin typeface="Segoe UI" charset="0"/>
@@ -15417,7 +15417,7 @@
                           <a:ea typeface="Segoe UI" pitchFamily="34" charset="-122"/>
                           <a:cs typeface="Segoe UI" pitchFamily="34" charset="-120"/>
                         </a:rPr>
-                        <a:t>A sunk ~794M + vận hành</a:t>
+                        <a:t>50% (B+C) + A sunk ~794M + vận hành</a:t>
                       </a:r>
                       <a:endParaRPr lang="en-US" sz="1100" dirty="0">
                         <a:latin typeface="Segoe UI" charset="0"/>
@@ -15555,7 +15555,7 @@
                           <a:ea typeface="Segoe UI" pitchFamily="34" charset="-122"/>
                           <a:cs typeface="Segoe UI" pitchFamily="34" charset="-120"/>
                         </a:rPr>
-                        <a:t>Nhà đầu tư 40-45% / dev 55-60%</a:t>
+                        <a:t>Nhà đầu tư ~40% / dev ~60%</a:t>
                       </a:r>
                       <a:endParaRPr lang="en-US" sz="1100" dirty="0">
                         <a:latin typeface="Segoe UI" charset="0"/>
@@ -15623,7 +15623,7 @@
                           <a:ea typeface="Segoe UI" pitchFamily="34" charset="-122"/>
                           <a:cs typeface="Segoe UI" pitchFamily="34" charset="-120"/>
                         </a:rPr>
-                        <a:t>Nhà đầu tư 60-65% / dev 35-40%</a:t>
+                        <a:t>Nhà đầu tư ~45% / dev ~55%</a:t>
                       </a:r>
                       <a:endParaRPr lang="en-US" sz="1100" dirty="0">
                         <a:latin typeface="Segoe UI" charset="0"/>
@@ -15693,7 +15693,7 @@
                           <a:ea typeface="Segoe UI" pitchFamily="34" charset="-122"/>
                           <a:cs typeface="Segoe UI" pitchFamily="34" charset="-120"/>
                         </a:rPr>
-                        <a:t>Recoup-first</a:t>
+                        <a:t>Cổ phần sau T03/2029</a:t>
                       </a:r>
                       <a:endParaRPr lang="en-US" sz="1100" dirty="0">
                         <a:latin typeface="Segoe UI" charset="0"/>
@@ -15761,7 +15761,7 @@
                           <a:ea typeface="Segoe UI" pitchFamily="34" charset="-122"/>
                           <a:cs typeface="Segoe UI" pitchFamily="34" charset="-120"/>
                         </a:rPr>
-                        <a:t>Share NĐT trừ gốc 829M; recoup xong còn ~30-35%</a:t>
+                        <a:t>~10-15%</a:t>
                       </a:r>
                       <a:endParaRPr lang="en-US" sz="1100" dirty="0">
                         <a:latin typeface="Segoe UI" charset="0"/>
@@ -15829,7 +15829,7 @@
                           <a:ea typeface="Segoe UI" pitchFamily="34" charset="-122"/>
                           <a:cs typeface="Segoe UI" pitchFamily="34" charset="-120"/>
                         </a:rPr>
-                        <a:t>Trừ trên tổng giải ngân; recoup xong còn ~40-45%</a:t>
+                        <a:t>~15-20% (cam kết lớn hơn)</a:t>
                       </a:r>
                       <a:endParaRPr lang="en-US" sz="1100" dirty="0">
                         <a:latin typeface="Segoe UI" charset="0"/>
@@ -15877,212 +15877,6 @@
                     </a:lnB>
                     <a:solidFill>
                       <a:srgbClr val="F8FAFC"/>
-                    </a:solidFill>
-                  </a:tcPr>
-                </a:tc>
-              </a:tr>
-              <a:tr h="502920">
-                <a:tc>
-                  <a:txBody>
-                    <a:bodyPr/>
-                    <a:lstStyle/>
-                    <a:p>
-                      <a:pPr indent="0" marL="0">
-                        <a:buNone/>
-                      </a:pPr>
-                      <a:r>
-                        <a:rPr lang="en-US" sz="1100" dirty="0">
-                          <a:solidFill>
-                            <a:srgbClr val="0F172A"/>
-                          </a:solidFill>
-                          <a:latin typeface="Segoe UI" pitchFamily="34" charset="0"/>
-                          <a:ea typeface="Segoe UI" pitchFamily="34" charset="-122"/>
-                          <a:cs typeface="Segoe UI" pitchFamily="34" charset="-120"/>
-                        </a:rPr>
-                        <a:t>Cổ phần sau T03/2029</a:t>
-                      </a:r>
-                      <a:endParaRPr lang="en-US" sz="1100" dirty="0">
-                        <a:latin typeface="Segoe UI" charset="0"/>
-                        <a:ea typeface="Segoe UI" charset="0"/>
-                        <a:cs typeface="Segoe UI" charset="0"/>
-                      </a:endParaRPr>
-                    </a:p>
-                  </a:txBody>
-                  <a:tcPr marL="54864" marR="54864" marT="54864" marB="54864" anchor="ctr">
-                    <a:lnL w="9525" cap="flat" cmpd="sng" algn="ctr">
-                      <a:solidFill>
-                        <a:srgbClr val="E2E8F0"/>
-                      </a:solidFill>
-                      <a:prstDash val="solid"/>
-                      <a:round/>
-                      <a:headEnd type="none" w="med" len="med"/>
-                      <a:tailEnd type="none" w="med" len="med"/>
-                    </a:lnL>
-                    <a:lnR w="9525" cap="flat" cmpd="sng" algn="ctr">
-                      <a:solidFill>
-                        <a:srgbClr val="E2E8F0"/>
-                      </a:solidFill>
-                      <a:prstDash val="solid"/>
-                      <a:round/>
-                      <a:headEnd type="none" w="med" len="med"/>
-                      <a:tailEnd type="none" w="med" len="med"/>
-                    </a:lnR>
-                    <a:lnT w="9525" cap="flat" cmpd="sng" algn="ctr">
-                      <a:solidFill>
-                        <a:srgbClr val="E2E8F0"/>
-                      </a:solidFill>
-                      <a:prstDash val="solid"/>
-                      <a:round/>
-                      <a:headEnd type="none" w="med" len="med"/>
-                      <a:tailEnd type="none" w="med" len="med"/>
-                    </a:lnT>
-                    <a:lnB w="9525" cap="flat" cmpd="sng" algn="ctr">
-                      <a:solidFill>
-                        <a:srgbClr val="E2E8F0"/>
-                      </a:solidFill>
-                      <a:prstDash val="solid"/>
-                      <a:round/>
-                      <a:headEnd type="none" w="med" len="med"/>
-                      <a:tailEnd type="none" w="med" len="med"/>
-                    </a:lnB>
-                    <a:solidFill>
-                      <a:srgbClr val="FFFFFF"/>
-                    </a:solidFill>
-                  </a:tcPr>
-                </a:tc>
-                <a:tc>
-                  <a:txBody>
-                    <a:bodyPr/>
-                    <a:lstStyle/>
-                    <a:p>
-                      <a:pPr indent="0" marL="0">
-                        <a:buNone/>
-                      </a:pPr>
-                      <a:r>
-                        <a:rPr lang="en-US" sz="1100" dirty="0">
-                          <a:solidFill>
-                            <a:srgbClr val="0F172A"/>
-                          </a:solidFill>
-                          <a:latin typeface="Segoe UI" pitchFamily="34" charset="0"/>
-                          <a:ea typeface="Segoe UI" pitchFamily="34" charset="-122"/>
-                          <a:cs typeface="Segoe UI" pitchFamily="34" charset="-120"/>
-                        </a:rPr>
-                        <a:t>~10-15%</a:t>
-                      </a:r>
-                      <a:endParaRPr lang="en-US" sz="1100" dirty="0">
-                        <a:latin typeface="Segoe UI" charset="0"/>
-                        <a:ea typeface="Segoe UI" charset="0"/>
-                        <a:cs typeface="Segoe UI" charset="0"/>
-                      </a:endParaRPr>
-                    </a:p>
-                  </a:txBody>
-                  <a:tcPr marL="54864" marR="54864" marT="54864" marB="54864" anchor="ctr">
-                    <a:lnL w="9525" cap="flat" cmpd="sng" algn="ctr">
-                      <a:solidFill>
-                        <a:srgbClr val="E2E8F0"/>
-                      </a:solidFill>
-                      <a:prstDash val="solid"/>
-                      <a:round/>
-                      <a:headEnd type="none" w="med" len="med"/>
-                      <a:tailEnd type="none" w="med" len="med"/>
-                    </a:lnL>
-                    <a:lnR w="9525" cap="flat" cmpd="sng" algn="ctr">
-                      <a:solidFill>
-                        <a:srgbClr val="E2E8F0"/>
-                      </a:solidFill>
-                      <a:prstDash val="solid"/>
-                      <a:round/>
-                      <a:headEnd type="none" w="med" len="med"/>
-                      <a:tailEnd type="none" w="med" len="med"/>
-                    </a:lnR>
-                    <a:lnT w="9525" cap="flat" cmpd="sng" algn="ctr">
-                      <a:solidFill>
-                        <a:srgbClr val="E2E8F0"/>
-                      </a:solidFill>
-                      <a:prstDash val="solid"/>
-                      <a:round/>
-                      <a:headEnd type="none" w="med" len="med"/>
-                      <a:tailEnd type="none" w="med" len="med"/>
-                    </a:lnT>
-                    <a:lnB w="9525" cap="flat" cmpd="sng" algn="ctr">
-                      <a:solidFill>
-                        <a:srgbClr val="E2E8F0"/>
-                      </a:solidFill>
-                      <a:prstDash val="solid"/>
-                      <a:round/>
-                      <a:headEnd type="none" w="med" len="med"/>
-                      <a:tailEnd type="none" w="med" len="med"/>
-                    </a:lnB>
-                    <a:solidFill>
-                      <a:srgbClr val="FFFFFF"/>
-                    </a:solidFill>
-                  </a:tcPr>
-                </a:tc>
-                <a:tc>
-                  <a:txBody>
-                    <a:bodyPr/>
-                    <a:lstStyle/>
-                    <a:p>
-                      <a:pPr indent="0" marL="0">
-                        <a:buNone/>
-                      </a:pPr>
-                      <a:r>
-                        <a:rPr lang="en-US" sz="1100" dirty="0">
-                          <a:solidFill>
-                            <a:srgbClr val="0F172A"/>
-                          </a:solidFill>
-                          <a:latin typeface="Segoe UI" pitchFamily="34" charset="0"/>
-                          <a:ea typeface="Segoe UI" pitchFamily="34" charset="-122"/>
-                          <a:cs typeface="Segoe UI" pitchFamily="34" charset="-120"/>
-                        </a:rPr>
-                        <a:t>~20-25%</a:t>
-                      </a:r>
-                      <a:endParaRPr lang="en-US" sz="1100" dirty="0">
-                        <a:latin typeface="Segoe UI" charset="0"/>
-                        <a:ea typeface="Segoe UI" charset="0"/>
-                        <a:cs typeface="Segoe UI" charset="0"/>
-                      </a:endParaRPr>
-                    </a:p>
-                  </a:txBody>
-                  <a:tcPr marL="54864" marR="54864" marT="54864" marB="54864" anchor="ctr">
-                    <a:lnL w="9525" cap="flat" cmpd="sng" algn="ctr">
-                      <a:solidFill>
-                        <a:srgbClr val="E2E8F0"/>
-                      </a:solidFill>
-                      <a:prstDash val="solid"/>
-                      <a:round/>
-                      <a:headEnd type="none" w="med" len="med"/>
-                      <a:tailEnd type="none" w="med" len="med"/>
-                    </a:lnL>
-                    <a:lnR w="9525" cap="flat" cmpd="sng" algn="ctr">
-                      <a:solidFill>
-                        <a:srgbClr val="E2E8F0"/>
-                      </a:solidFill>
-                      <a:prstDash val="solid"/>
-                      <a:round/>
-                      <a:headEnd type="none" w="med" len="med"/>
-                      <a:tailEnd type="none" w="med" len="med"/>
-                    </a:lnR>
-                    <a:lnT w="9525" cap="flat" cmpd="sng" algn="ctr">
-                      <a:solidFill>
-                        <a:srgbClr val="E2E8F0"/>
-                      </a:solidFill>
-                      <a:prstDash val="solid"/>
-                      <a:round/>
-                      <a:headEnd type="none" w="med" len="med"/>
-                      <a:tailEnd type="none" w="med" len="med"/>
-                    </a:lnT>
-                    <a:lnB w="9525" cap="flat" cmpd="sng" algn="ctr">
-                      <a:solidFill>
-                        <a:srgbClr val="E2E8F0"/>
-                      </a:solidFill>
-                      <a:prstDash val="solid"/>
-                      <a:round/>
-                      <a:headEnd type="none" w="med" len="med"/>
-                      <a:tailEnd type="none" w="med" len="med"/>
-                    </a:lnB>
-                    <a:solidFill>
-                      <a:srgbClr val="FFFFFF"/>
                     </a:solidFill>
                   </a:tcPr>
                 </a:tc>
@@ -16124,7 +15918,7 @@
                 <a:ea typeface="Segoe UI" pitchFamily="34" charset="-122"/>
                 <a:cs typeface="Segoe UI" pitchFamily="34" charset="-120"/>
               </a:rPr>
-              <a:t>Nhà đầu tư được share cao hơn tỷ lệ vốn đóng góp (bù rủi ro early); dev giữ majority/IP vì gánh sunk A + maintain + vận hành.</a:t>
+              <a:t>Share-risk 50-50 về chi phí ở cả 2 phương án; dev giữ majority rev-share vì gánh sunk A + IP + toàn bộ công sức vận hành.</a:t>
             </a:r>
             <a:endParaRPr lang="en-US" sz="1050" dirty="0"/>
           </a:p>
@@ -16782,7 +16576,7 @@
                           <a:ea typeface="Segoe UI" pitchFamily="34" charset="-122"/>
                           <a:cs typeface="Segoe UI" pitchFamily="34" charset="-120"/>
                         </a:rPr>
-                        <a:t>Phần B ~829M → NĐT 40-45% rev-share 2 năm + ~10-15% cổ phần sau 2029</a:t>
+                        <a:t>NĐT gánh 50% B ≈ ~414.7M → NĐT ~40% rev-share 2 năm + ~10-15% cổ phần sau 2029</a:t>
                       </a:r>
                       <a:endParaRPr lang="en-US" sz="1100" dirty="0">
                         <a:latin typeface="Segoe UI" charset="0"/>
@@ -16920,7 +16714,7 @@
                           <a:ea typeface="Segoe UI" pitchFamily="34" charset="-122"/>
                           <a:cs typeface="Segoe UI" pitchFamily="34" charset="-120"/>
                         </a:rPr>
-                        <a:t>B+C ~1 995M → NĐT 60-65% rev-share 2 năm + ~20-25% cổ phần sau 2029</a:t>
+                        <a:t>NĐT gánh 50% (B+C) ≈ ~997.5M → NĐT ~45% rev-share 2 năm + ~15-20% cổ phần sau 2029</a:t>
                       </a:r>
                       <a:endParaRPr lang="en-US" sz="1100" dirty="0">
                         <a:latin typeface="Segoe UI" charset="0"/>

</xml_diff>